<commit_message>
Update with new NMDS plot
</commit_message>
<xml_diff>
--- a/Figures and tables final data set.pptx
+++ b/Figures and tables final data set.pptx
@@ -116,6 +116,11 @@
       </a:defRPr>
     </a:lvl9pPr>
   </p:defaultTextStyle>
+  <p:extLst>
+    <p:ext uri="{EFAFB233-063F-42B5-8137-9DF3F51BA10A}">
+      <p15:sldGuideLst xmlns:p15="http://schemas.microsoft.com/office/powerpoint/2012/main"/>
+    </p:ext>
+  </p:extLst>
 </p:presentation>
 </file>
 
@@ -266,7 +271,7 @@
           <a:p>
             <a:fld id="{BE76205E-E917-4F89-9EAE-D9F9DED07A8F}" type="datetimeFigureOut">
               <a:rPr lang="en-US" smtClean="0"/>
-              <a:t>8/12/2026</a:t>
+              <a:t>8/14/2026</a:t>
             </a:fld>
             <a:endParaRPr lang="en-US"/>
           </a:p>
@@ -464,7 +469,7 @@
           <a:p>
             <a:fld id="{BE76205E-E917-4F89-9EAE-D9F9DED07A8F}" type="datetimeFigureOut">
               <a:rPr lang="en-US" smtClean="0"/>
-              <a:t>8/12/2026</a:t>
+              <a:t>8/14/2026</a:t>
             </a:fld>
             <a:endParaRPr lang="en-US"/>
           </a:p>
@@ -672,7 +677,7 @@
           <a:p>
             <a:fld id="{BE76205E-E917-4F89-9EAE-D9F9DED07A8F}" type="datetimeFigureOut">
               <a:rPr lang="en-US" smtClean="0"/>
-              <a:t>8/12/2026</a:t>
+              <a:t>8/14/2026</a:t>
             </a:fld>
             <a:endParaRPr lang="en-US"/>
           </a:p>
@@ -870,7 +875,7 @@
           <a:p>
             <a:fld id="{BE76205E-E917-4F89-9EAE-D9F9DED07A8F}" type="datetimeFigureOut">
               <a:rPr lang="en-US" smtClean="0"/>
-              <a:t>8/12/2026</a:t>
+              <a:t>8/14/2026</a:t>
             </a:fld>
             <a:endParaRPr lang="en-US"/>
           </a:p>
@@ -1145,7 +1150,7 @@
           <a:p>
             <a:fld id="{BE76205E-E917-4F89-9EAE-D9F9DED07A8F}" type="datetimeFigureOut">
               <a:rPr lang="en-US" smtClean="0"/>
-              <a:t>8/12/2026</a:t>
+              <a:t>8/14/2026</a:t>
             </a:fld>
             <a:endParaRPr lang="en-US"/>
           </a:p>
@@ -1410,7 +1415,7 @@
           <a:p>
             <a:fld id="{BE76205E-E917-4F89-9EAE-D9F9DED07A8F}" type="datetimeFigureOut">
               <a:rPr lang="en-US" smtClean="0"/>
-              <a:t>8/12/2026</a:t>
+              <a:t>8/14/2026</a:t>
             </a:fld>
             <a:endParaRPr lang="en-US"/>
           </a:p>
@@ -1822,7 +1827,7 @@
           <a:p>
             <a:fld id="{BE76205E-E917-4F89-9EAE-D9F9DED07A8F}" type="datetimeFigureOut">
               <a:rPr lang="en-US" smtClean="0"/>
-              <a:t>8/12/2026</a:t>
+              <a:t>8/14/2026</a:t>
             </a:fld>
             <a:endParaRPr lang="en-US"/>
           </a:p>
@@ -1963,7 +1968,7 @@
           <a:p>
             <a:fld id="{BE76205E-E917-4F89-9EAE-D9F9DED07A8F}" type="datetimeFigureOut">
               <a:rPr lang="en-US" smtClean="0"/>
-              <a:t>8/12/2026</a:t>
+              <a:t>8/14/2026</a:t>
             </a:fld>
             <a:endParaRPr lang="en-US"/>
           </a:p>
@@ -2076,7 +2081,7 @@
           <a:p>
             <a:fld id="{BE76205E-E917-4F89-9EAE-D9F9DED07A8F}" type="datetimeFigureOut">
               <a:rPr lang="en-US" smtClean="0"/>
-              <a:t>8/12/2026</a:t>
+              <a:t>8/14/2026</a:t>
             </a:fld>
             <a:endParaRPr lang="en-US"/>
           </a:p>
@@ -2387,7 +2392,7 @@
           <a:p>
             <a:fld id="{BE76205E-E917-4F89-9EAE-D9F9DED07A8F}" type="datetimeFigureOut">
               <a:rPr lang="en-US" smtClean="0"/>
-              <a:t>8/12/2026</a:t>
+              <a:t>8/14/2026</a:t>
             </a:fld>
             <a:endParaRPr lang="en-US"/>
           </a:p>
@@ -2675,7 +2680,7 @@
           <a:p>
             <a:fld id="{BE76205E-E917-4F89-9EAE-D9F9DED07A8F}" type="datetimeFigureOut">
               <a:rPr lang="en-US" smtClean="0"/>
-              <a:t>8/12/2026</a:t>
+              <a:t>8/14/2026</a:t>
             </a:fld>
             <a:endParaRPr lang="en-US"/>
           </a:p>
@@ -2916,7 +2921,7 @@
           <a:p>
             <a:fld id="{BE76205E-E917-4F89-9EAE-D9F9DED07A8F}" type="datetimeFigureOut">
               <a:rPr lang="en-US" smtClean="0"/>
-              <a:t>8/12/2026</a:t>
+              <a:t>8/14/2026</a:t>
             </a:fld>
             <a:endParaRPr lang="en-US"/>
           </a:p>
@@ -4877,10 +4882,10 @@
       </p:sp>
       <p:pic>
         <p:nvPicPr>
-          <p:cNvPr id="7" name="Picture 6">
-            <a:extLst>
-              <a:ext uri="{FF2B5EF4-FFF2-40B4-BE49-F238E27FC236}">
-                <a16:creationId xmlns:a16="http://schemas.microsoft.com/office/drawing/2014/main" id="{C25FD911-CE2D-9919-7FCE-33C8CFEDE292}"/>
+          <p:cNvPr id="4" name="Picture 3">
+            <a:extLst>
+              <a:ext uri="{FF2B5EF4-FFF2-40B4-BE49-F238E27FC236}">
+                <a16:creationId xmlns:a16="http://schemas.microsoft.com/office/drawing/2014/main" id="{505DB7AE-32B4-0DD1-7939-4F0FDCAD4E24}"/>
               </a:ext>
             </a:extLst>
           </p:cNvPr>
@@ -6197,10 +6202,10 @@
       </p:sp>
       <p:pic>
         <p:nvPicPr>
-          <p:cNvPr id="9" name="Picture 8">
-            <a:extLst>
-              <a:ext uri="{FF2B5EF4-FFF2-40B4-BE49-F238E27FC236}">
-                <a16:creationId xmlns:a16="http://schemas.microsoft.com/office/drawing/2014/main" id="{DC299D87-D8C2-9D79-8269-EF6096FA21C5}"/>
+          <p:cNvPr id="4" name="Picture 3">
+            <a:extLst>
+              <a:ext uri="{FF2B5EF4-FFF2-40B4-BE49-F238E27FC236}">
+                <a16:creationId xmlns:a16="http://schemas.microsoft.com/office/drawing/2014/main" id="{A20AA7C5-2BE5-EC28-81CC-CC4F01F5B5EC}"/>
               </a:ext>
             </a:extLst>
           </p:cNvPr>

</xml_diff>